<commit_message>
docs: align submission with demo and business case
</commit_message>
<xml_diff>
--- a/submission/Sanjiv_ET_AI_Hackathon_Pitch_Deck_Final.pptx
+++ b/submission/Sanjiv_ET_AI_Hackathon_Pitch_Deck_Final.pptx
@@ -2,24 +2,24 @@
 <file path=ppt/presentation.xml><?xml version="1.0" encoding="utf-8"?>
 <p:presentation xmlns:p="http://schemas.openxmlformats.org/presentationml/2006/main">
   <p:sldMasterIdLst>
-    <p:sldMasterId xmlns:r="http://schemas.openxmlformats.org/officeDocument/2006/relationships" id="2147483648" r:id="Rf7d93e0160634a7c"/>
+    <p:sldMasterId xmlns:r="http://schemas.openxmlformats.org/officeDocument/2006/relationships" id="2147483648" r:id="R4f5f9fde887a4483"/>
   </p:sldMasterIdLst>
   <p:notesMasterIdLst>
-    <p:notesMasterId xmlns:r="http://schemas.openxmlformats.org/officeDocument/2006/relationships" r:id="R358ec620093644d6"/>
+    <p:notesMasterId xmlns:r="http://schemas.openxmlformats.org/officeDocument/2006/relationships" r:id="R67329699a66c4ade"/>
   </p:notesMasterIdLst>
   <p:sldIdLst>
-    <p:sldId xmlns:r="http://schemas.openxmlformats.org/officeDocument/2006/relationships" id="256" r:id="R99e48aa270a44afa"/>
-    <p:sldId xmlns:r="http://schemas.openxmlformats.org/officeDocument/2006/relationships" id="257" r:id="R59ecb282e6594dfb"/>
-    <p:sldId xmlns:r="http://schemas.openxmlformats.org/officeDocument/2006/relationships" id="258" r:id="R526991beb26e41b6"/>
-    <p:sldId xmlns:r="http://schemas.openxmlformats.org/officeDocument/2006/relationships" id="259" r:id="Ra9e9d88242f04feb"/>
-    <p:sldId xmlns:r="http://schemas.openxmlformats.org/officeDocument/2006/relationships" id="260" r:id="R701815b2b6f94c43"/>
-    <p:sldId xmlns:r="http://schemas.openxmlformats.org/officeDocument/2006/relationships" id="261" r:id="R07245453f8ab4aac"/>
-    <p:sldId xmlns:r="http://schemas.openxmlformats.org/officeDocument/2006/relationships" id="262" r:id="R1be1346f0a3748d8"/>
-    <p:sldId xmlns:r="http://schemas.openxmlformats.org/officeDocument/2006/relationships" id="263" r:id="R6781edc1ad5d4b90"/>
-    <p:sldId xmlns:r="http://schemas.openxmlformats.org/officeDocument/2006/relationships" id="264" r:id="Rf9a58ab296b646ae"/>
-    <p:sldId xmlns:r="http://schemas.openxmlformats.org/officeDocument/2006/relationships" id="265" r:id="Rfd403f791c0941f3"/>
-    <p:sldId xmlns:r="http://schemas.openxmlformats.org/officeDocument/2006/relationships" id="266" r:id="R320b6eddb2c54c06"/>
-    <p:sldId xmlns:r="http://schemas.openxmlformats.org/officeDocument/2006/relationships" id="267" r:id="Re39a23d938c44bec"/>
+    <p:sldId xmlns:r="http://schemas.openxmlformats.org/officeDocument/2006/relationships" id="256" r:id="R5e8befbfc2854f83"/>
+    <p:sldId xmlns:r="http://schemas.openxmlformats.org/officeDocument/2006/relationships" id="257" r:id="Rcd2803a20ce6465b"/>
+    <p:sldId xmlns:r="http://schemas.openxmlformats.org/officeDocument/2006/relationships" id="258" r:id="Rf37e537dde6e4f21"/>
+    <p:sldId xmlns:r="http://schemas.openxmlformats.org/officeDocument/2006/relationships" id="259" r:id="R5b4f861686d24b6f"/>
+    <p:sldId xmlns:r="http://schemas.openxmlformats.org/officeDocument/2006/relationships" id="260" r:id="Rf1a8787a7ced4af1"/>
+    <p:sldId xmlns:r="http://schemas.openxmlformats.org/officeDocument/2006/relationships" id="261" r:id="R4401019558b84e18"/>
+    <p:sldId xmlns:r="http://schemas.openxmlformats.org/officeDocument/2006/relationships" id="262" r:id="Ra623bcda95624bdd"/>
+    <p:sldId xmlns:r="http://schemas.openxmlformats.org/officeDocument/2006/relationships" id="263" r:id="R833dbc7e8fe54b4e"/>
+    <p:sldId xmlns:r="http://schemas.openxmlformats.org/officeDocument/2006/relationships" id="264" r:id="R3c06a36f28b44fde"/>
+    <p:sldId xmlns:r="http://schemas.openxmlformats.org/officeDocument/2006/relationships" id="265" r:id="R5d3b6f123dbe46e3"/>
+    <p:sldId xmlns:r="http://schemas.openxmlformats.org/officeDocument/2006/relationships" id="266" r:id="R765bda7e44f9424c"/>
+    <p:sldId xmlns:r="http://schemas.openxmlformats.org/officeDocument/2006/relationships" id="267" r:id="R0d37ac8d6d6647d0"/>
   </p:sldIdLst>
   <p:sldSz cx="12191695" cy="6858000"/>
   <p:notesSz cx="6858000" cy="9144000"/>
@@ -1426,7 +1426,7 @@
   </p:cSld>
   <p:clrMap bg1="lt1" tx1="dk1" bg2="lt2" tx2="dk2" accent1="accent1" accent2="accent2" accent3="accent3" accent4="accent4" accent5="accent5" accent6="accent6" hlink="hlink" folHlink="folHlink"/>
   <p:sldLayoutIdLst>
-    <p:sldLayoutId xmlns:r="http://schemas.openxmlformats.org/officeDocument/2006/relationships" id="2147483649" r:id="Rd7539ceef6f1478b"/>
+    <p:sldLayoutId xmlns:r="http://schemas.openxmlformats.org/officeDocument/2006/relationships" id="2147483649" r:id="R1328acebe0e9489f"/>
   </p:sldLayoutIdLst>
   <p:hf sldNum="0" hdr="0" ftr="0" dt="0"/>
   <p:txStyles>
@@ -2266,7 +2266,7 @@
                   <a:srgbClr val="C8D9EF"/>
                 </a:solidFill>
               </a:rPr>
-              <a:t>Current UI | 212 tests | 8 verified product screens</a:t>
+              <a:t>Current UI | 212 tests | 3:55 submitted demo</a:t>
             </a:r>
           </a:p>
         </p:txBody>
@@ -4708,7 +4708,7 @@
                 <a:ea typeface="Aptos Display"/>
                 <a:cs typeface="Aptos Display"/>
               </a:rPr>
-              <a:t>One crisis. One complete decision loop.</a:t>
+              <a:t>A 3 min 55 sec demo of a pilot-ready decision loop.</a:t>
             </a:r>
           </a:p>
         </p:txBody>
@@ -4750,7 +4750,7 @@
                   <a:srgbClr val="5D6B82"/>
                 </a:solidFill>
               </a:rPr>
-              <a:t>Real application footage, a human cursor, a current public observation and explicit replay boundaries.</a:t>
+              <a:t>The submitted video turns an observed public signal into a governed response package; the pilot starts in shadow mode, without autonomous execution.</a:t>
             </a:r>
           </a:p>
         </p:txBody>
@@ -4834,7 +4834,7 @@
                   <a:srgbClr val="152033"/>
                 </a:solidFill>
               </a:rPr>
-              <a:t>Open Maritime: OBSERVED/CURRENT PortWatch + replay AIS layer</a:t>
+              <a:t>Observe current PortWatch alongside replay context</a:t>
             </a:r>
           </a:p>
         </p:txBody>
@@ -4918,7 +4918,7 @@
                   <a:srgbClr val="152033"/>
                 </a:solidFill>
               </a:rPr>
-              <a:t>Inspect Hormuz risk severity / confidence / completeness</a:t>
+              <a:t>Inspect risk, confidence and data completeness</a:t>
             </a:r>
           </a:p>
         </p:txBody>
@@ -5002,7 +5002,7 @@
                   <a:srgbClr val="152033"/>
                 </a:solidFill>
               </a:rPr>
-              <a:t>Compile “Close the Strait of Hormuz for 14 days”</a:t>
+              <a:t>Confirm one business disruption scenario</a:t>
             </a:r>
           </a:p>
         </p:txBody>
@@ -5086,7 +5086,7 @@
                   <a:srgbClr val="152033"/>
                 </a:solidFill>
               </a:rPr>
-              <a:t>Run no-action simulation and show shortfall</a:t>
+              <a:t>See the no-action shortfall and impact</a:t>
             </a:r>
           </a:p>
         </p:txBody>
@@ -5170,7 +5170,7 @@
                   <a:srgbClr val="152033"/>
                 </a:solidFill>
               </a:rPr>
-              <a:t>Compare three procurement plans</a:t>
+              <a:t>Compare cost, continuity and concentration trade-offs</a:t>
             </a:r>
           </a:p>
         </p:txBody>
@@ -5254,7 +5254,7 @@
                   <a:srgbClr val="152033"/>
                 </a:solidFill>
               </a:rPr>
-              <a:t>Coordinate strategic reserve policy</a:t>
+              <a:t>Check reserve policy without inventing fill</a:t>
             </a:r>
           </a:p>
         </p:txBody>
@@ -5338,7 +5338,7 @@
                   <a:srgbClr val="152033"/>
                 </a:solidFill>
               </a:rPr>
-              <a:t>Open Why this plan + evidence drawer</a:t>
+              <a:t>Open the evidence and decision rationale</a:t>
             </a:r>
           </a:p>
         </p:txBody>
@@ -5422,7 +5422,7 @@
                   <a:srgbClr val="152033"/>
                 </a:solidFill>
               </a:rPr>
-              <a:t>Submit for review / approval</a:t>
+              <a:t>Record human review and approval</a:t>
             </a:r>
           </a:p>
         </p:txBody>
@@ -5506,7 +5506,7 @@
                   <a:srgbClr val="152033"/>
                 </a:solidFill>
               </a:rPr>
-              <a:t>Close on monitored command center</a:t>
+              <a:t>Monitor the declared replay outcome</a:t>
             </a:r>
           </a:p>
         </p:txBody>
@@ -5548,7 +5548,7 @@
                   <a:srgbClr val="081426"/>
                 </a:solidFill>
               </a:rPr>
-              <a:t>Target: 3:00-3:30. Lead with the observed signal, show the checked decision chain, and close on human approval plus monitored evidence.</a:t>
+              <a:t>Submitted demo length: 3 min 55 sec. Business adoption begins with one corridor, one commodity and shadow-mode use alongside existing governance.</a:t>
             </a:r>
           </a:p>
         </p:txBody>
@@ -5769,7 +5769,7 @@
         </p:spPr>
         <p:txBody>
           <a:bodyPr xmlns:a="http://schemas.openxmlformats.org/drawingml/2006/main" wrap="square" lIns="0" tIns="0" rIns="0" bIns="0" anchor="ctr">
-            <a:normAutofit/>
+            <a:normAutofit fontScale="72000"/>
           </a:bodyPr>
           <a:lstStyle xmlns:a="http://schemas.openxmlformats.org/drawingml/2006/main"/>
           <a:p xmlns:a="http://schemas.openxmlformats.org/drawingml/2006/main">
@@ -5782,7 +5782,7 @@
                   <a:srgbClr val="EAF3FF"/>
                 </a:solidFill>
               </a:rPr>
-              <a:t>A live threat appears - or a user types one. Sanjiv shows what is exposed, what happens without intervention, and the best defensible action to take.</a:t>
+              <a:t>A current public signal arrives - or an analyst defines a scenario. Sanjiv gives risk, procurement and reserve teams one common, auditable decision package: what is observed, what is modeled, and what needs human sign-off.</a:t>
             </a:r>
           </a:p>
         </p:txBody>
@@ -5866,7 +5866,55 @@
                   <a:srgbClr val="D7E8FF"/>
                 </a:solidFill>
               </a:rPr>
-              <a:t>Human authority. Audited metrics. Deterministic response options.</a:t>
+              <a:t>Business value: explainable trade-offs, human authority and a monitored outcome.</a:t>
+            </a:r>
+          </a:p>
+          <a:p xmlns:a="http://schemas.openxmlformats.org/drawingml/2006/main">
+            <a:pPr marL="0" indent="0">
+              <a:buNone/>
+            </a:pPr>
+            <a:r>
+              <a:rPr sz="1300">
+                <a:solidFill>
+                  <a:srgbClr val="D7E8FF"/>
+                </a:solidFill>
+                <a:hlinkClick xmlns:r="http://schemas.openxmlformats.org/officeDocument/2006/relationships" r:id="R95d24170d34d4037"/>
+              </a:rPr>
+              <a:t>GitHub</a:t>
+            </a:r>
+            <a:r>
+              <a:rPr sz="1300">
+                <a:solidFill>
+                  <a:srgbClr val="D7E8FF"/>
+                </a:solidFill>
+              </a:rPr>
+              <a:t>  |  </a:t>
+            </a:r>
+            <a:r>
+              <a:rPr sz="1300">
+                <a:solidFill>
+                  <a:srgbClr val="D7E8FF"/>
+                </a:solidFill>
+                <a:hlinkClick xmlns:r="http://schemas.openxmlformats.org/officeDocument/2006/relationships" r:id="R7d07d8848b1044a2"/>
+              </a:rPr>
+              <a:t>Demo</a:t>
+            </a:r>
+            <a:r>
+              <a:rPr sz="1300">
+                <a:solidFill>
+                  <a:srgbClr val="D7E8FF"/>
+                </a:solidFill>
+              </a:rPr>
+              <a:t>  |  </a:t>
+            </a:r>
+            <a:r>
+              <a:rPr sz="1300">
+                <a:solidFill>
+                  <a:srgbClr val="D7E8FF"/>
+                </a:solidFill>
+                <a:hlinkClick xmlns:r="http://schemas.openxmlformats.org/officeDocument/2006/relationships" r:id="R566dc35c424d4280"/>
+              </a:rPr>
+              <a:t>vivekyarra567@gmail.com</a:t>
             </a:r>
           </a:p>
         </p:txBody>
@@ -6484,7 +6532,7 @@
                 <a:ea typeface="Aptos Display"/>
                 <a:cs typeface="Aptos Display"/>
               </a:rPr>
-              <a:t>The crisis is not lack of data. It is lack of decision intelligence.</a:t>
+              <a:t>A supply shock is a business decision, not just a data problem.</a:t>
             </a:r>
           </a:p>
         </p:txBody>
@@ -6526,7 +6574,7 @@
                   <a:srgbClr val="5D6B82"/>
                 </a:solidFill>
               </a:rPr>
-              <a:t>India must connect fragmented maritime, geopolitical, refinery, procurement and reserve signals fast enough to act.</a:t>
+              <a:t>Energy teams need a shared, auditable path from a corridor signal to a decision they can defend.</a:t>
             </a:r>
           </a:p>
         </p:txBody>
@@ -6568,7 +6616,7 @@
                   <a:srgbClr val="081426"/>
                 </a:solidFill>
               </a:rPr>
-              <a:t>The risk</a:t>
+              <a:t>What breaks in the operating model</a:t>
             </a:r>
           </a:p>
         </p:txBody>
@@ -6599,7 +6647,7 @@
         </p:spPr>
         <p:txBody>
           <a:bodyPr xmlns:a="http://schemas.openxmlformats.org/drawingml/2006/main" wrap="square" lIns="254" tIns="254" rIns="254" bIns="254" anchor="ctr">
-            <a:normAutofit/>
+            <a:normAutofit fontScale="100000"/>
           </a:bodyPr>
           <a:lstStyle xmlns:a="http://schemas.openxmlformats.org/drawingml/2006/main"/>
           <a:p xmlns:a="http://schemas.openxmlformats.org/drawingml/2006/main">
@@ -6609,7 +6657,7 @@
                   <a:srgbClr val="152033"/>
                 </a:solidFill>
               </a:rPr>
-              <a:t>A disruption starts at a corridor, but the consequence lands at refineries, prices, inventories and procurement desks.</a:t>
+              <a:t>A disruption hits continuity, exposure, inventory and procurement at once. Fragmented dashboards do not give teams a common decision package.</a:t>
             </a:r>
           </a:p>
           <a:p xmlns:a="http://schemas.openxmlformats.org/drawingml/2006/main">
@@ -6619,17 +6667,7 @@
                   <a:srgbClr val="152033"/>
                 </a:solidFill>
               </a:rPr>
-              <a:t>Traditional dashboards show signals; they do not produce defensible response options.</a:t>
-            </a:r>
-          </a:p>
-          <a:p xmlns:a="http://schemas.openxmlformats.org/drawingml/2006/main">
-            <a:r>
-              <a:rPr sz="1300">
-                <a:solidFill>
-                  <a:srgbClr val="152033"/>
-                </a:solidFill>
-              </a:rPr>
-              <a:t>Under uncertainty, unsupported claims are as dangerous as missing data.</a:t>
+              <a:t>Under uncertainty, unsupported claims are as risky as missing data.</a:t>
             </a:r>
           </a:p>
         </p:txBody>
@@ -6671,7 +6709,7 @@
                   <a:srgbClr val="081426"/>
                 </a:solidFill>
               </a:rPr>
-              <a:t>Sanjiv’s answer</a:t>
+              <a:t>What Sanjiv makes possible</a:t>
             </a:r>
           </a:p>
         </p:txBody>
@@ -6702,7 +6740,7 @@
         </p:spPr>
         <p:txBody>
           <a:bodyPr xmlns:a="http://schemas.openxmlformats.org/drawingml/2006/main" wrap="square" lIns="254" tIns="254" rIns="254" bIns="254" anchor="ctr">
-            <a:normAutofit/>
+            <a:normAutofit fontScale="100000"/>
           </a:bodyPr>
           <a:lstStyle xmlns:a="http://schemas.openxmlformats.org/drawingml/2006/main"/>
           <a:p xmlns:a="http://schemas.openxmlformats.org/drawingml/2006/main">
@@ -6712,7 +6750,7 @@
                   <a:srgbClr val="152033"/>
                 </a:solidFill>
               </a:rPr>
-              <a:t>Model the no-action consequence.</a:t>
+              <a:t>Test the no-action consequence.</a:t>
             </a:r>
           </a:p>
           <a:p xmlns:a="http://schemas.openxmlformats.org/drawingml/2006/main">
@@ -6722,7 +6760,7 @@
                   <a:srgbClr val="152033"/>
                 </a:solidFill>
               </a:rPr>
-              <a:t>Optimise checked procurement alternatives.</a:t>
+              <a:t>Compare cost, continuity and concentration trade-offs.</a:t>
             </a:r>
           </a:p>
           <a:p xmlns:a="http://schemas.openxmlformats.org/drawingml/2006/main">
@@ -6732,7 +6770,7 @@
                   <a:srgbClr val="152033"/>
                 </a:solidFill>
               </a:rPr>
-              <a:t>Coordinate strategic reserve policy.</a:t>
+              <a:t>Carry evidence and assumptions into approval.</a:t>
             </a:r>
           </a:p>
           <a:p xmlns:a="http://schemas.openxmlformats.org/drawingml/2006/main">
@@ -6742,7 +6780,7 @@
                   <a:srgbClr val="152033"/>
                 </a:solidFill>
               </a:rPr>
-              <a:t>Make every KPI auditable before approval.</a:t>
+              <a:t>Monitor the declared outcome after a decision.</a:t>
             </a:r>
           </a:p>
         </p:txBody>
@@ -9070,7 +9108,7 @@
           <p:nvPr/>
         </p:nvPicPr>
         <p:blipFill>
-          <a:blip xmlns:r="http://schemas.openxmlformats.org/officeDocument/2006/relationships" xmlns:a="http://schemas.openxmlformats.org/drawingml/2006/main" r:embed="R4b8be71fca06468d"/>
+          <a:blip xmlns:r="http://schemas.openxmlformats.org/officeDocument/2006/relationships" xmlns:a="http://schemas.openxmlformats.org/drawingml/2006/main" r:embed="Rd3dfd44f95d04904"/>
           <a:stretch xmlns:a="http://schemas.openxmlformats.org/drawingml/2006/main"/>
         </p:blipFill>
         <p:spPr>
@@ -9094,7 +9132,7 @@
           <p:nvPr/>
         </p:nvPicPr>
         <p:blipFill>
-          <a:blip xmlns:r="http://schemas.openxmlformats.org/officeDocument/2006/relationships" xmlns:a="http://schemas.openxmlformats.org/drawingml/2006/main" r:embed="R60ead5902a004739"/>
+          <a:blip xmlns:r="http://schemas.openxmlformats.org/officeDocument/2006/relationships" xmlns:a="http://schemas.openxmlformats.org/drawingml/2006/main" r:embed="Rf503c110bc8b4c81"/>
           <a:stretch xmlns:a="http://schemas.openxmlformats.org/drawingml/2006/main"/>
         </p:blipFill>
         <p:spPr>
@@ -9624,7 +9662,7 @@
           <p:nvPr/>
         </p:nvPicPr>
         <p:blipFill>
-          <a:blip xmlns:r="http://schemas.openxmlformats.org/officeDocument/2006/relationships" xmlns:a="http://schemas.openxmlformats.org/drawingml/2006/main" r:embed="R1c81b3e3b2aa4024"/>
+          <a:blip xmlns:r="http://schemas.openxmlformats.org/officeDocument/2006/relationships" xmlns:a="http://schemas.openxmlformats.org/drawingml/2006/main" r:embed="Ra9af595509b548c3"/>
           <a:stretch xmlns:a="http://schemas.openxmlformats.org/drawingml/2006/main"/>
         </p:blipFill>
         <p:spPr>
@@ -9648,7 +9686,7 @@
           <p:nvPr/>
         </p:nvPicPr>
         <p:blipFill>
-          <a:blip xmlns:r="http://schemas.openxmlformats.org/officeDocument/2006/relationships" xmlns:a="http://schemas.openxmlformats.org/drawingml/2006/main" r:embed="R27cbb3c3a8894aed"/>
+          <a:blip xmlns:r="http://schemas.openxmlformats.org/officeDocument/2006/relationships" xmlns:a="http://schemas.openxmlformats.org/drawingml/2006/main" r:embed="Rc42c247681d9486e"/>
           <a:stretch xmlns:a="http://schemas.openxmlformats.org/drawingml/2006/main"/>
         </p:blipFill>
         <p:spPr>
@@ -10178,7 +10216,7 @@
           <p:nvPr/>
         </p:nvPicPr>
         <p:blipFill>
-          <a:blip xmlns:r="http://schemas.openxmlformats.org/officeDocument/2006/relationships" xmlns:a="http://schemas.openxmlformats.org/drawingml/2006/main" r:embed="R17f10ad0f26143bb"/>
+          <a:blip xmlns:r="http://schemas.openxmlformats.org/officeDocument/2006/relationships" xmlns:a="http://schemas.openxmlformats.org/drawingml/2006/main" r:embed="R95fdecc4a4a349bb"/>
           <a:stretch xmlns:a="http://schemas.openxmlformats.org/drawingml/2006/main"/>
         </p:blipFill>
         <p:spPr>
@@ -10202,7 +10240,7 @@
           <p:nvPr/>
         </p:nvPicPr>
         <p:blipFill>
-          <a:blip xmlns:r="http://schemas.openxmlformats.org/officeDocument/2006/relationships" xmlns:a="http://schemas.openxmlformats.org/drawingml/2006/main" r:embed="R7b4d70b04a60491a"/>
+          <a:blip xmlns:r="http://schemas.openxmlformats.org/officeDocument/2006/relationships" xmlns:a="http://schemas.openxmlformats.org/drawingml/2006/main" r:embed="Rfdfd08bd924c4a14"/>
           <a:stretch xmlns:a="http://schemas.openxmlformats.org/drawingml/2006/main"/>
         </p:blipFill>
         <p:spPr>
@@ -10732,7 +10770,7 @@
           <p:nvPr/>
         </p:nvPicPr>
         <p:blipFill>
-          <a:blip xmlns:r="http://schemas.openxmlformats.org/officeDocument/2006/relationships" xmlns:a="http://schemas.openxmlformats.org/drawingml/2006/main" r:embed="R98916f30e4c24c3b"/>
+          <a:blip xmlns:r="http://schemas.openxmlformats.org/officeDocument/2006/relationships" xmlns:a="http://schemas.openxmlformats.org/drawingml/2006/main" r:embed="Re8ab436730cf4d92"/>
           <a:stretch xmlns:a="http://schemas.openxmlformats.org/drawingml/2006/main"/>
         </p:blipFill>
         <p:spPr>
@@ -10756,7 +10794,7 @@
           <p:nvPr/>
         </p:nvPicPr>
         <p:blipFill>
-          <a:blip xmlns:r="http://schemas.openxmlformats.org/officeDocument/2006/relationships" xmlns:a="http://schemas.openxmlformats.org/drawingml/2006/main" r:embed="Rf622046de4414453"/>
+          <a:blip xmlns:r="http://schemas.openxmlformats.org/officeDocument/2006/relationships" xmlns:a="http://schemas.openxmlformats.org/drawingml/2006/main" r:embed="R890facb79dc94444"/>
           <a:stretch xmlns:a="http://schemas.openxmlformats.org/drawingml/2006/main"/>
         </p:blipFill>
         <p:spPr>

</xml_diff>

<commit_message>
docs: update submitted demo link
</commit_message>
<xml_diff>
--- a/submission/Sanjiv_ET_AI_Hackathon_Pitch_Deck_Final.pptx
+++ b/submission/Sanjiv_ET_AI_Hackathon_Pitch_Deck_Final.pptx
@@ -2,24 +2,24 @@
 <file path=ppt/presentation.xml><?xml version="1.0" encoding="utf-8"?>
 <p:presentation xmlns:p="http://schemas.openxmlformats.org/presentationml/2006/main">
   <p:sldMasterIdLst>
-    <p:sldMasterId xmlns:r="http://schemas.openxmlformats.org/officeDocument/2006/relationships" id="2147483648" r:id="R4f5f9fde887a4483"/>
+    <p:sldMasterId xmlns:r="http://schemas.openxmlformats.org/officeDocument/2006/relationships" id="2147483648" r:id="R77fe77a047d8437f"/>
   </p:sldMasterIdLst>
   <p:notesMasterIdLst>
-    <p:notesMasterId xmlns:r="http://schemas.openxmlformats.org/officeDocument/2006/relationships" r:id="R67329699a66c4ade"/>
+    <p:notesMasterId xmlns:r="http://schemas.openxmlformats.org/officeDocument/2006/relationships" r:id="Ra3ab5abdae534504"/>
   </p:notesMasterIdLst>
   <p:sldIdLst>
-    <p:sldId xmlns:r="http://schemas.openxmlformats.org/officeDocument/2006/relationships" id="256" r:id="R5e8befbfc2854f83"/>
-    <p:sldId xmlns:r="http://schemas.openxmlformats.org/officeDocument/2006/relationships" id="257" r:id="Rcd2803a20ce6465b"/>
-    <p:sldId xmlns:r="http://schemas.openxmlformats.org/officeDocument/2006/relationships" id="258" r:id="Rf37e537dde6e4f21"/>
-    <p:sldId xmlns:r="http://schemas.openxmlformats.org/officeDocument/2006/relationships" id="259" r:id="R5b4f861686d24b6f"/>
-    <p:sldId xmlns:r="http://schemas.openxmlformats.org/officeDocument/2006/relationships" id="260" r:id="Rf1a8787a7ced4af1"/>
-    <p:sldId xmlns:r="http://schemas.openxmlformats.org/officeDocument/2006/relationships" id="261" r:id="R4401019558b84e18"/>
-    <p:sldId xmlns:r="http://schemas.openxmlformats.org/officeDocument/2006/relationships" id="262" r:id="Ra623bcda95624bdd"/>
-    <p:sldId xmlns:r="http://schemas.openxmlformats.org/officeDocument/2006/relationships" id="263" r:id="R833dbc7e8fe54b4e"/>
-    <p:sldId xmlns:r="http://schemas.openxmlformats.org/officeDocument/2006/relationships" id="264" r:id="R3c06a36f28b44fde"/>
-    <p:sldId xmlns:r="http://schemas.openxmlformats.org/officeDocument/2006/relationships" id="265" r:id="R5d3b6f123dbe46e3"/>
-    <p:sldId xmlns:r="http://schemas.openxmlformats.org/officeDocument/2006/relationships" id="266" r:id="R765bda7e44f9424c"/>
-    <p:sldId xmlns:r="http://schemas.openxmlformats.org/officeDocument/2006/relationships" id="267" r:id="R0d37ac8d6d6647d0"/>
+    <p:sldId xmlns:r="http://schemas.openxmlformats.org/officeDocument/2006/relationships" id="256" r:id="Rff0f362c6e9b4e6e"/>
+    <p:sldId xmlns:r="http://schemas.openxmlformats.org/officeDocument/2006/relationships" id="257" r:id="R0d4865a6f06347b2"/>
+    <p:sldId xmlns:r="http://schemas.openxmlformats.org/officeDocument/2006/relationships" id="258" r:id="Rd88905cf3d33417c"/>
+    <p:sldId xmlns:r="http://schemas.openxmlformats.org/officeDocument/2006/relationships" id="259" r:id="Rb3464d60e72741df"/>
+    <p:sldId xmlns:r="http://schemas.openxmlformats.org/officeDocument/2006/relationships" id="260" r:id="R3aa9a25ee0ad4236"/>
+    <p:sldId xmlns:r="http://schemas.openxmlformats.org/officeDocument/2006/relationships" id="261" r:id="Rff515fe143294a67"/>
+    <p:sldId xmlns:r="http://schemas.openxmlformats.org/officeDocument/2006/relationships" id="262" r:id="Rda5895e4ad3a4b44"/>
+    <p:sldId xmlns:r="http://schemas.openxmlformats.org/officeDocument/2006/relationships" id="263" r:id="R5b6cfcabf3434bde"/>
+    <p:sldId xmlns:r="http://schemas.openxmlformats.org/officeDocument/2006/relationships" id="264" r:id="R2dcc651e3dac49be"/>
+    <p:sldId xmlns:r="http://schemas.openxmlformats.org/officeDocument/2006/relationships" id="265" r:id="Rea9cb1c41e784353"/>
+    <p:sldId xmlns:r="http://schemas.openxmlformats.org/officeDocument/2006/relationships" id="266" r:id="R8f6b8dcc8b684adf"/>
+    <p:sldId xmlns:r="http://schemas.openxmlformats.org/officeDocument/2006/relationships" id="267" r:id="R9427189fe4c040a1"/>
   </p:sldIdLst>
   <p:sldSz cx="12191695" cy="6858000"/>
   <p:notesSz cx="6858000" cy="9144000"/>
@@ -1426,7 +1426,7 @@
   </p:cSld>
   <p:clrMap bg1="lt1" tx1="dk1" bg2="lt2" tx2="dk2" accent1="accent1" accent2="accent2" accent3="accent3" accent4="accent4" accent5="accent5" accent6="accent6" hlink="hlink" folHlink="folHlink"/>
   <p:sldLayoutIdLst>
-    <p:sldLayoutId xmlns:r="http://schemas.openxmlformats.org/officeDocument/2006/relationships" id="2147483649" r:id="R1328acebe0e9489f"/>
+    <p:sldLayoutId xmlns:r="http://schemas.openxmlformats.org/officeDocument/2006/relationships" id="2147483649" r:id="R8430c7931dbb4dd6"/>
   </p:sldLayoutIdLst>
   <p:hf sldNum="0" hdr="0" ftr="0" dt="0"/>
   <p:txStyles>
@@ -5878,7 +5878,7 @@
                 <a:solidFill>
                   <a:srgbClr val="D7E8FF"/>
                 </a:solidFill>
-                <a:hlinkClick xmlns:r="http://schemas.openxmlformats.org/officeDocument/2006/relationships" r:id="R95d24170d34d4037"/>
+                <a:hlinkClick xmlns:r="http://schemas.openxmlformats.org/officeDocument/2006/relationships" r:id="Rf4396649c3824b20"/>
               </a:rPr>
               <a:t>GitHub</a:t>
             </a:r>
@@ -5895,7 +5895,7 @@
                 <a:solidFill>
                   <a:srgbClr val="D7E8FF"/>
                 </a:solidFill>
-                <a:hlinkClick xmlns:r="http://schemas.openxmlformats.org/officeDocument/2006/relationships" r:id="R7d07d8848b1044a2"/>
+                <a:hlinkClick xmlns:r="http://schemas.openxmlformats.org/officeDocument/2006/relationships" r:id="Rc096a192dc5b4b73"/>
               </a:rPr>
               <a:t>Demo</a:t>
             </a:r>
@@ -5912,7 +5912,7 @@
                 <a:solidFill>
                   <a:srgbClr val="D7E8FF"/>
                 </a:solidFill>
-                <a:hlinkClick xmlns:r="http://schemas.openxmlformats.org/officeDocument/2006/relationships" r:id="R566dc35c424d4280"/>
+                <a:hlinkClick xmlns:r="http://schemas.openxmlformats.org/officeDocument/2006/relationships" r:id="R12cfb60a83f84fef"/>
               </a:rPr>
               <a:t>vivekyarra567@gmail.com</a:t>
             </a:r>
@@ -9108,7 +9108,7 @@
           <p:nvPr/>
         </p:nvPicPr>
         <p:blipFill>
-          <a:blip xmlns:r="http://schemas.openxmlformats.org/officeDocument/2006/relationships" xmlns:a="http://schemas.openxmlformats.org/drawingml/2006/main" r:embed="Rd3dfd44f95d04904"/>
+          <a:blip xmlns:r="http://schemas.openxmlformats.org/officeDocument/2006/relationships" xmlns:a="http://schemas.openxmlformats.org/drawingml/2006/main" r:embed="Re159eb5b3b2c4ef2"/>
           <a:stretch xmlns:a="http://schemas.openxmlformats.org/drawingml/2006/main"/>
         </p:blipFill>
         <p:spPr>
@@ -9132,7 +9132,7 @@
           <p:nvPr/>
         </p:nvPicPr>
         <p:blipFill>
-          <a:blip xmlns:r="http://schemas.openxmlformats.org/officeDocument/2006/relationships" xmlns:a="http://schemas.openxmlformats.org/drawingml/2006/main" r:embed="Rf503c110bc8b4c81"/>
+          <a:blip xmlns:r="http://schemas.openxmlformats.org/officeDocument/2006/relationships" xmlns:a="http://schemas.openxmlformats.org/drawingml/2006/main" r:embed="R75d1ddbb2a1a4e9d"/>
           <a:stretch xmlns:a="http://schemas.openxmlformats.org/drawingml/2006/main"/>
         </p:blipFill>
         <p:spPr>
@@ -9662,7 +9662,7 @@
           <p:nvPr/>
         </p:nvPicPr>
         <p:blipFill>
-          <a:blip xmlns:r="http://schemas.openxmlformats.org/officeDocument/2006/relationships" xmlns:a="http://schemas.openxmlformats.org/drawingml/2006/main" r:embed="Ra9af595509b548c3"/>
+          <a:blip xmlns:r="http://schemas.openxmlformats.org/officeDocument/2006/relationships" xmlns:a="http://schemas.openxmlformats.org/drawingml/2006/main" r:embed="Re851d9cdf245408b"/>
           <a:stretch xmlns:a="http://schemas.openxmlformats.org/drawingml/2006/main"/>
         </p:blipFill>
         <p:spPr>
@@ -9686,7 +9686,7 @@
           <p:nvPr/>
         </p:nvPicPr>
         <p:blipFill>
-          <a:blip xmlns:r="http://schemas.openxmlformats.org/officeDocument/2006/relationships" xmlns:a="http://schemas.openxmlformats.org/drawingml/2006/main" r:embed="Rc42c247681d9486e"/>
+          <a:blip xmlns:r="http://schemas.openxmlformats.org/officeDocument/2006/relationships" xmlns:a="http://schemas.openxmlformats.org/drawingml/2006/main" r:embed="R5d2e906e984a47fa"/>
           <a:stretch xmlns:a="http://schemas.openxmlformats.org/drawingml/2006/main"/>
         </p:blipFill>
         <p:spPr>
@@ -10216,7 +10216,7 @@
           <p:nvPr/>
         </p:nvPicPr>
         <p:blipFill>
-          <a:blip xmlns:r="http://schemas.openxmlformats.org/officeDocument/2006/relationships" xmlns:a="http://schemas.openxmlformats.org/drawingml/2006/main" r:embed="R95fdecc4a4a349bb"/>
+          <a:blip xmlns:r="http://schemas.openxmlformats.org/officeDocument/2006/relationships" xmlns:a="http://schemas.openxmlformats.org/drawingml/2006/main" r:embed="Rb3be8f563bb64a0e"/>
           <a:stretch xmlns:a="http://schemas.openxmlformats.org/drawingml/2006/main"/>
         </p:blipFill>
         <p:spPr>
@@ -10240,7 +10240,7 @@
           <p:nvPr/>
         </p:nvPicPr>
         <p:blipFill>
-          <a:blip xmlns:r="http://schemas.openxmlformats.org/officeDocument/2006/relationships" xmlns:a="http://schemas.openxmlformats.org/drawingml/2006/main" r:embed="Rfdfd08bd924c4a14"/>
+          <a:blip xmlns:r="http://schemas.openxmlformats.org/officeDocument/2006/relationships" xmlns:a="http://schemas.openxmlformats.org/drawingml/2006/main" r:embed="R132c533b36e34d79"/>
           <a:stretch xmlns:a="http://schemas.openxmlformats.org/drawingml/2006/main"/>
         </p:blipFill>
         <p:spPr>
@@ -10770,7 +10770,7 @@
           <p:nvPr/>
         </p:nvPicPr>
         <p:blipFill>
-          <a:blip xmlns:r="http://schemas.openxmlformats.org/officeDocument/2006/relationships" xmlns:a="http://schemas.openxmlformats.org/drawingml/2006/main" r:embed="Re8ab436730cf4d92"/>
+          <a:blip xmlns:r="http://schemas.openxmlformats.org/officeDocument/2006/relationships" xmlns:a="http://schemas.openxmlformats.org/drawingml/2006/main" r:embed="Racf0649e67a04704"/>
           <a:stretch xmlns:a="http://schemas.openxmlformats.org/drawingml/2006/main"/>
         </p:blipFill>
         <p:spPr>
@@ -10794,7 +10794,7 @@
           <p:nvPr/>
         </p:nvPicPr>
         <p:blipFill>
-          <a:blip xmlns:r="http://schemas.openxmlformats.org/officeDocument/2006/relationships" xmlns:a="http://schemas.openxmlformats.org/drawingml/2006/main" r:embed="R890facb79dc94444"/>
+          <a:blip xmlns:r="http://schemas.openxmlformats.org/officeDocument/2006/relationships" xmlns:a="http://schemas.openxmlformats.org/drawingml/2006/main" r:embed="R1d4aa1aa7d39464e"/>
           <a:stretch xmlns:a="http://schemas.openxmlformats.org/drawingml/2006/main"/>
         </p:blipFill>
         <p:spPr>

</xml_diff>